<commit_message>
W01 D3: Anand asks for the reconciliation before the day closes, not by five
The half-two deck's opening quote, the escalated case, the hands-on notebook and
its build script put a clock time in Anand's mouth. Lesson material carries
durations only; the deck is rebuilt from its markdown.

Co-Authored-By: Claude Opus 5.5 <noreply@anthropic.com>
Claude-Session: https://claude.ai/code/session_01P7zaoR4dQ5pzBFnsX549JQ
</commit_message>
<xml_diff>
--- a/content/W01/D3/slides/C2_W01_D03_half2_STUDENT.pptx
+++ b/content/W01/D3/slides/C2_W01_D03_half2_STUDENT.pptx
@@ -5229,7 +5229,7 @@
                 </a:solidFill>
                 <a:latin typeface="Georgia"/>
               </a:rPr>
-              <a:t>“Send the reconciliation and the log by five. My analyst checks it tonight.”</a:t>
+              <a:t>“Send the reconciliation and the log before the day closes. My analyst checks it tonight.”</a:t>
             </a:r>
           </a:p>
         </p:txBody>
@@ -5932,7 +5932,7 @@
       </p:sp>
       <p:pic>
         <p:nvPicPr>
-          <p:cNvPr id="9" name="mermaid diagram" descr="423b4cf95e4e117b.png"/>
+          <p:cNvPr id="9" name="mermaid diagram" descr="7899268401913962.png"/>
           <p:cNvPicPr>
             <a:picLocks noChangeAspect="1"/>
           </p:cNvPicPr>
@@ -5947,7 +5947,7 @@
         <p:spPr>
           <a:xfrm>
             <a:off x="530352" y="1956816"/>
-            <a:ext cx="11130991" cy="1547548"/>
+            <a:ext cx="11130991" cy="1043117"/>
           </a:xfrm>
           <a:prstGeom prst="rect">
             <a:avLst/>
@@ -6764,7 +6764,7 @@
       </p:sp>
       <p:pic>
         <p:nvPicPr>
-          <p:cNvPr id="12" name="mermaid diagram" descr="6d102f071eabba83.png"/>
+          <p:cNvPr id="12" name="mermaid diagram" descr="d4242e17dd0e7bf1.png"/>
           <p:cNvPicPr>
             <a:picLocks noChangeAspect="1"/>
           </p:cNvPicPr>
@@ -6778,8 +6778,8 @@
         </p:blipFill>
         <p:spPr>
           <a:xfrm>
-            <a:off x="3424085" y="3195828"/>
-            <a:ext cx="5343525" cy="2586037"/>
+            <a:off x="3695547" y="3195828"/>
+            <a:ext cx="4800600" cy="2328862"/>
           </a:xfrm>
           <a:prstGeom prst="rect">
             <a:avLst/>
@@ -9106,7 +9106,7 @@
                 </a:solidFill>
                 <a:latin typeface="Calibri"/>
               </a:rPr>
-              <a:t>Week 1 Day 3: the reconciliation Anand can audit</a:t>
+              <a:t>Week 1, Day 3. The reconciliation Anand can audit</a:t>
             </a:r>
           </a:p>
         </p:txBody>
@@ -11765,7 +11765,7 @@
                 </a:solidFill>
                 <a:latin typeface="Calibri"/>
               </a:rPr>
-              <a:t>Week 1 Day 3: the reconciliation Anand can audit</a:t>
+              <a:t>Week 1, Day 3. The reconciliation Anand can audit</a:t>
             </a:r>
           </a:p>
         </p:txBody>
@@ -12144,7 +12144,7 @@
       </p:sp>
       <p:pic>
         <p:nvPicPr>
-          <p:cNvPr id="11" name="mermaid diagram" descr="e1c13290219456e0.png"/>
+          <p:cNvPr id="11" name="mermaid diagram" descr="a1b4ae782c2ead99.png"/>
           <p:cNvPicPr>
             <a:picLocks noChangeAspect="1"/>
           </p:cNvPicPr>
@@ -12158,8 +12158,8 @@
         </p:blipFill>
         <p:spPr>
           <a:xfrm>
-            <a:off x="2152497" y="3413760"/>
-            <a:ext cx="7886700" cy="1100137"/>
+            <a:off x="2988316" y="3413760"/>
+            <a:ext cx="6215062" cy="614362"/>
           </a:xfrm>
           <a:prstGeom prst="rect">
             <a:avLst/>
@@ -14045,7 +14045,7 @@
       </p:sp>
       <p:pic>
         <p:nvPicPr>
-          <p:cNvPr id="14" name="mermaid diagram" descr="84310f6268e2ad62.png"/>
+          <p:cNvPr id="14" name="mermaid diagram" descr="d4aa7568b490a150.png"/>
           <p:cNvPicPr>
             <a:picLocks noChangeAspect="1"/>
           </p:cNvPicPr>
@@ -14059,8 +14059,8 @@
         </p:blipFill>
         <p:spPr>
           <a:xfrm>
-            <a:off x="3424085" y="3243072"/>
-            <a:ext cx="5343525" cy="2586037"/>
+            <a:off x="3716978" y="3243072"/>
+            <a:ext cx="4757737" cy="2257425"/>
           </a:xfrm>
           <a:prstGeom prst="rect">
             <a:avLst/>
@@ -15078,7 +15078,7 @@
                 </a:solidFill>
                 <a:latin typeface="Calibri"/>
               </a:rPr>
-              <a:t>Week 1 Day 3: the reconciliation Anand can audit</a:t>
+              <a:t>Week 1, Day 3. The reconciliation Anand can audit</a:t>
             </a:r>
           </a:p>
         </p:txBody>
@@ -18319,7 +18319,7 @@
       </p:sp>
       <p:pic>
         <p:nvPicPr>
-          <p:cNvPr id="9" name="mermaid diagram" descr="ba0e9ab613d50080.png"/>
+          <p:cNvPr id="9" name="mermaid diagram" descr="e1edfac1a48cfc9c.png"/>
           <p:cNvPicPr>
             <a:picLocks noChangeAspect="1"/>
           </p:cNvPicPr>
@@ -18333,8 +18333,8 @@
         </p:blipFill>
         <p:spPr>
           <a:xfrm>
-            <a:off x="780897" y="1956816"/>
-            <a:ext cx="10629900" cy="2786062"/>
+            <a:off x="1316678" y="1956816"/>
+            <a:ext cx="9558337" cy="1800225"/>
           </a:xfrm>
           <a:prstGeom prst="rect">
             <a:avLst/>
@@ -20619,7 +20619,7 @@
                 </a:solidFill>
                 <a:latin typeface="Calibri"/>
               </a:rPr>
-              <a:t>Week 1 Day 3: the reconciliation Anand can audit</a:t>
+              <a:t>Week 1, Day 3. The reconciliation Anand can audit</a:t>
             </a:r>
           </a:p>
         </p:txBody>
@@ -21940,7 +21940,7 @@
       </p:sp>
       <p:pic>
         <p:nvPicPr>
-          <p:cNvPr id="9" name="mermaid diagram" descr="eef6138c8c8408a9.png"/>
+          <p:cNvPr id="9" name="mermaid diagram" descr="2d6ba8a20c9c7241.png"/>
           <p:cNvPicPr>
             <a:picLocks noChangeAspect="1"/>
           </p:cNvPicPr>
@@ -21954,8 +21954,8 @@
         </p:blipFill>
         <p:spPr>
           <a:xfrm>
-            <a:off x="780897" y="1956816"/>
-            <a:ext cx="10629900" cy="1357312"/>
+            <a:off x="738035" y="1956816"/>
+            <a:ext cx="10715625" cy="871537"/>
           </a:xfrm>
           <a:prstGeom prst="rect">
             <a:avLst/>
@@ -21970,7 +21970,7 @@
         </p:nvSpPr>
         <p:spPr>
           <a:xfrm>
-            <a:off x="530352" y="3460432"/>
+            <a:off x="530352" y="2974657"/>
             <a:ext cx="11130991" cy="862584"/>
           </a:xfrm>
           <a:prstGeom prst="roundRect">
@@ -22024,7 +22024,7 @@
         </p:nvSpPr>
         <p:spPr>
           <a:xfrm>
-            <a:off x="758952" y="3663124"/>
+            <a:off x="758952" y="3177349"/>
             <a:ext cx="457200" cy="457200"/>
           </a:xfrm>
           <a:prstGeom prst="ellipse">
@@ -22076,7 +22076,7 @@
         </p:blipFill>
         <p:spPr>
           <a:xfrm>
-            <a:off x="868680" y="3772852"/>
+            <a:off x="868680" y="3287077"/>
             <a:ext cx="237744" cy="237744"/>
           </a:xfrm>
           <a:prstGeom prst="rect">
@@ -22092,7 +22092,7 @@
         </p:nvSpPr>
         <p:spPr>
           <a:xfrm>
-            <a:off x="1399031" y="3606736"/>
+            <a:off x="1399031" y="3120961"/>
             <a:ext cx="9987991" cy="160401"/>
           </a:xfrm>
           <a:prstGeom prst="rect">
@@ -22127,7 +22127,7 @@
         </p:nvSpPr>
         <p:spPr>
           <a:xfrm>
-            <a:off x="1399031" y="3826192"/>
+            <a:off x="1399031" y="3340417"/>
             <a:ext cx="9987991" cy="423672"/>
           </a:xfrm>
           <a:prstGeom prst="rect">
@@ -23164,7 +23164,7 @@
                 </a:solidFill>
                 <a:latin typeface="Calibri"/>
               </a:rPr>
-              <a:t>Week 1 Day 3: the reconciliation Anand can audit</a:t>
+              <a:t>Week 1, Day 3. The reconciliation Anand can audit</a:t>
             </a:r>
           </a:p>
         </p:txBody>

</xml_diff>

<commit_message>
W01 D3: depth loop round one fixes: a true fuzzy match and corrected sizings, opener prose, two runtime items replaced, fix-the-logic and match items in the escalated brief, jargon defined, minutes balanced, cheat sheet panel one reshaped
</commit_message>
<xml_diff>
--- a/content/W01/D3/slides/C2_W01_D03_half2_STUDENT.pptx
+++ b/content/W01/D3/slides/C2_W01_D03_half2_STUDENT.pptx
@@ -752,7 +752,7 @@
           <a:lstStyle/>
           <a:p>
             <a:r>
-              <a:t>LIVE, 3 minutes. Notebook 06 asserts the replay equals the clean file.</a:t>
+              <a:t>LIVE, 2 minutes. Notebook 06 asserts the replay equals the clean file.</a:t>
             </a:r>
           </a:p>
         </p:txBody>
@@ -822,7 +822,7 @@
           <a:lstStyle/>
           <a:p>
             <a:r>
-              <a:t>LIVE, 2 minutes. One breath: set aside, not dropped; the rule, the twin, the rupees by segment,</a:t>
+              <a:t>LIVE, 2 minutes. One breath: set aside with a reason, never dropped; the rule, the twin, the rupees by segment,</a:t>
             </a:r>
           </a:p>
           <a:p>
@@ -2507,7 +2507,7 @@
           <a:lstStyle/>
           <a:p>
             <a:r>
-              <a:t>LIVE, 3 minutes. The decisions log has five lines; only the identity rule moves Q1 rupees, all</a:t>
+              <a:t>LIVE, 2 minutes. The decisions log has five lines; only the identity rule moves Q1 rupees, all</a:t>
             </a:r>
           </a:p>
           <a:p>
@@ -14096,7 +14096,7 @@
         <p:spPr>
           <a:xfrm>
             <a:off x="530352" y="676656"/>
-            <a:ext cx="11130991" cy="512064"/>
+            <a:ext cx="10033711" cy="512064"/>
           </a:xfrm>
           <a:prstGeom prst="rect">
             <a:avLst/>
@@ -14124,7 +14124,62 @@
       </p:sp>
       <p:sp>
         <p:nvSpPr>
-          <p:cNvPr id="8" name="TextBox 7"/>
+          <p:cNvPr id="8" name="Rounded Rectangle 7"/>
+          <p:cNvSpPr/>
+          <p:nvPr/>
+        </p:nvSpPr>
+        <p:spPr>
+          <a:xfrm>
+            <a:off x="10701223" y="822960"/>
+            <a:ext cx="960120" cy="256032"/>
+          </a:xfrm>
+          <a:prstGeom prst="roundRect">
+            <a:avLst>
+              <a:gd name="adj" fmla="val 50000"/>
+            </a:avLst>
+          </a:prstGeom>
+          <a:solidFill>
+            <a:srgbClr val="1A0F5C"/>
+          </a:solidFill>
+          <a:ln>
+            <a:noFill/>
+          </a:ln>
+          <a:effectLst/>
+        </p:spPr>
+        <p:style>
+          <a:lnRef idx="1">
+            <a:schemeClr val="accent1"/>
+          </a:lnRef>
+          <a:fillRef idx="3">
+            <a:schemeClr val="accent1"/>
+          </a:fillRef>
+          <a:effectRef idx="2">
+            <a:schemeClr val="accent1"/>
+          </a:effectRef>
+          <a:fontRef idx="minor">
+            <a:schemeClr val="lt1"/>
+          </a:fontRef>
+        </p:style>
+        <p:txBody>
+          <a:bodyPr rtlCol="0" anchor="ctr" wrap="none" lIns="25400" rIns="25400" tIns="0" bIns="0"/>
+          <a:lstStyle/>
+          <a:p>
+            <a:pPr algn="ctr"/>
+            <a:r>
+              <a:rPr sz="800" b="1" spc="200">
+                <a:solidFill>
+                  <a:srgbClr val="FFFFFF"/>
+                </a:solidFill>
+                <a:latin typeface="Calibri"/>
+              </a:rPr>
+              <a:t>DEPTH</a:t>
+            </a:r>
+          </a:p>
+        </p:txBody>
+      </p:sp>
+      <p:sp>
+        <p:nvSpPr>
+          <p:cNvPr id="9" name="TextBox 8"/>
           <p:cNvSpPr txBox="1"/>
           <p:nvPr/>
         </p:nvSpPr>
@@ -14159,7 +14214,7 @@
       </p:sp>
       <p:sp>
         <p:nvSpPr>
-          <p:cNvPr id="9" name="TextBox 8"/>
+          <p:cNvPr id="10" name="TextBox 9"/>
           <p:cNvSpPr txBox="1"/>
           <p:nvPr/>
         </p:nvSpPr>
@@ -14194,7 +14249,7 @@
       </p:sp>
       <p:sp>
         <p:nvSpPr>
-          <p:cNvPr id="10" name="TextBox 9"/>
+          <p:cNvPr id="11" name="TextBox 10"/>
           <p:cNvSpPr txBox="1"/>
           <p:nvPr/>
         </p:nvSpPr>
@@ -14229,7 +14284,7 @@
       </p:sp>
       <p:sp>
         <p:nvSpPr>
-          <p:cNvPr id="11" name="TextBox 10"/>
+          <p:cNvPr id="12" name="TextBox 11"/>
           <p:cNvSpPr txBox="1"/>
           <p:nvPr/>
         </p:nvSpPr>
@@ -14264,7 +14319,7 @@
       </p:sp>
       <p:sp>
         <p:nvSpPr>
-          <p:cNvPr id="12" name="Rectangle 11"/>
+          <p:cNvPr id="13" name="Rectangle 12"/>
           <p:cNvSpPr/>
           <p:nvPr/>
         </p:nvSpPr>
@@ -14308,7 +14363,7 @@
       </p:sp>
       <p:sp>
         <p:nvSpPr>
-          <p:cNvPr id="13" name="TextBox 12"/>
+          <p:cNvPr id="14" name="TextBox 13"/>
           <p:cNvSpPr txBox="1"/>
           <p:nvPr/>
         </p:nvSpPr>
@@ -14343,7 +14398,7 @@
       </p:sp>
       <p:sp>
         <p:nvSpPr>
-          <p:cNvPr id="14" name="TextBox 13"/>
+          <p:cNvPr id="15" name="TextBox 14"/>
           <p:cNvSpPr txBox="1"/>
           <p:nvPr/>
         </p:nvSpPr>
@@ -14378,7 +14433,7 @@
       </p:sp>
       <p:sp>
         <p:nvSpPr>
-          <p:cNvPr id="15" name="TextBox 14"/>
+          <p:cNvPr id="16" name="TextBox 15"/>
           <p:cNvSpPr txBox="1"/>
           <p:nvPr/>
         </p:nvSpPr>
@@ -14413,7 +14468,7 @@
       </p:sp>
       <p:sp>
         <p:nvSpPr>
-          <p:cNvPr id="16" name="Rectangle 15"/>
+          <p:cNvPr id="17" name="Rectangle 16"/>
           <p:cNvSpPr/>
           <p:nvPr/>
         </p:nvSpPr>
@@ -14457,7 +14512,7 @@
       </p:sp>
       <p:sp>
         <p:nvSpPr>
-          <p:cNvPr id="17" name="TextBox 16"/>
+          <p:cNvPr id="18" name="TextBox 17"/>
           <p:cNvSpPr txBox="1"/>
           <p:nvPr/>
         </p:nvSpPr>
@@ -14492,7 +14547,7 @@
       </p:sp>
       <p:sp>
         <p:nvSpPr>
-          <p:cNvPr id="18" name="TextBox 17"/>
+          <p:cNvPr id="19" name="TextBox 18"/>
           <p:cNvSpPr txBox="1"/>
           <p:nvPr/>
         </p:nvSpPr>
@@ -14527,7 +14582,7 @@
       </p:sp>
       <p:sp>
         <p:nvSpPr>
-          <p:cNvPr id="19" name="TextBox 18"/>
+          <p:cNvPr id="20" name="TextBox 19"/>
           <p:cNvSpPr txBox="1"/>
           <p:nvPr/>
         </p:nvSpPr>
@@ -14562,7 +14617,7 @@
       </p:sp>
       <p:sp>
         <p:nvSpPr>
-          <p:cNvPr id="20" name="Rectangle 19"/>
+          <p:cNvPr id="21" name="Rectangle 20"/>
           <p:cNvSpPr/>
           <p:nvPr/>
         </p:nvSpPr>
@@ -14606,7 +14661,7 @@
       </p:sp>
       <p:sp>
         <p:nvSpPr>
-          <p:cNvPr id="21" name="TextBox 20"/>
+          <p:cNvPr id="22" name="TextBox 21"/>
           <p:cNvSpPr txBox="1"/>
           <p:nvPr/>
         </p:nvSpPr>
@@ -14641,7 +14696,7 @@
       </p:sp>
       <p:sp>
         <p:nvSpPr>
-          <p:cNvPr id="22" name="TextBox 21"/>
+          <p:cNvPr id="23" name="TextBox 22"/>
           <p:cNvSpPr txBox="1"/>
           <p:nvPr/>
         </p:nvSpPr>
@@ -14676,7 +14731,7 @@
       </p:sp>
       <p:sp>
         <p:nvSpPr>
-          <p:cNvPr id="23" name="TextBox 22"/>
+          <p:cNvPr id="24" name="TextBox 23"/>
           <p:cNvSpPr txBox="1"/>
           <p:nvPr/>
         </p:nvSpPr>
@@ -14711,7 +14766,7 @@
       </p:sp>
       <p:sp>
         <p:nvSpPr>
-          <p:cNvPr id="24" name="Rectangle 23"/>
+          <p:cNvPr id="25" name="Rectangle 24"/>
           <p:cNvSpPr/>
           <p:nvPr/>
         </p:nvSpPr>
@@ -14755,7 +14810,7 @@
       </p:sp>
       <p:sp>
         <p:nvSpPr>
-          <p:cNvPr id="25" name="Oval 24"/>
+          <p:cNvPr id="26" name="Oval 25"/>
           <p:cNvSpPr/>
           <p:nvPr/>
         </p:nvSpPr>
@@ -14799,7 +14854,7 @@
       </p:sp>
       <p:sp>
         <p:nvSpPr>
-          <p:cNvPr id="26" name="TextBox 25"/>
+          <p:cNvPr id="27" name="TextBox 26"/>
           <p:cNvSpPr txBox="1"/>
           <p:nvPr/>
         </p:nvSpPr>
@@ -14834,7 +14889,7 @@
       </p:sp>
       <p:sp>
         <p:nvSpPr>
-          <p:cNvPr id="27" name="Oval 26"/>
+          <p:cNvPr id="28" name="Oval 27"/>
           <p:cNvSpPr/>
           <p:nvPr/>
         </p:nvSpPr>
@@ -14878,7 +14933,7 @@
       </p:sp>
       <p:sp>
         <p:nvSpPr>
-          <p:cNvPr id="28" name="TextBox 27"/>
+          <p:cNvPr id="29" name="TextBox 28"/>
           <p:cNvSpPr txBox="1"/>
           <p:nvPr/>
         </p:nvSpPr>
@@ -14913,7 +14968,7 @@
       </p:sp>
       <p:sp>
         <p:nvSpPr>
-          <p:cNvPr id="29" name="Oval 28"/>
+          <p:cNvPr id="30" name="Oval 29"/>
           <p:cNvSpPr/>
           <p:nvPr/>
         </p:nvSpPr>
@@ -14957,7 +15012,7 @@
       </p:sp>
       <p:sp>
         <p:nvSpPr>
-          <p:cNvPr id="30" name="TextBox 29"/>
+          <p:cNvPr id="31" name="TextBox 30"/>
           <p:cNvSpPr txBox="1"/>
           <p:nvPr/>
         </p:nvSpPr>
@@ -14992,7 +15047,7 @@
       </p:sp>
       <p:sp>
         <p:nvSpPr>
-          <p:cNvPr id="31" name="Oval 30"/>
+          <p:cNvPr id="32" name="Oval 31"/>
           <p:cNvSpPr/>
           <p:nvPr/>
         </p:nvSpPr>
@@ -15036,7 +15091,7 @@
       </p:sp>
       <p:sp>
         <p:nvSpPr>
-          <p:cNvPr id="32" name="TextBox 31"/>
+          <p:cNvPr id="33" name="TextBox 32"/>
           <p:cNvSpPr txBox="1"/>
           <p:nvPr/>
         </p:nvSpPr>
@@ -15071,7 +15126,7 @@
       </p:sp>
       <p:sp>
         <p:nvSpPr>
-          <p:cNvPr id="33" name="Oval 32"/>
+          <p:cNvPr id="34" name="Oval 33"/>
           <p:cNvSpPr/>
           <p:nvPr/>
         </p:nvSpPr>
@@ -15115,7 +15170,7 @@
       </p:sp>
       <p:sp>
         <p:nvSpPr>
-          <p:cNvPr id="34" name="TextBox 33"/>
+          <p:cNvPr id="35" name="TextBox 34"/>
           <p:cNvSpPr txBox="1"/>
           <p:nvPr/>
         </p:nvSpPr>
@@ -15150,7 +15205,7 @@
       </p:sp>
       <p:sp>
         <p:nvSpPr>
-          <p:cNvPr id="35" name="Oval 34"/>
+          <p:cNvPr id="36" name="Oval 35"/>
           <p:cNvSpPr/>
           <p:nvPr/>
         </p:nvSpPr>
@@ -15194,7 +15249,7 @@
       </p:sp>
       <p:sp>
         <p:nvSpPr>
-          <p:cNvPr id="36" name="TextBox 35"/>
+          <p:cNvPr id="37" name="TextBox 36"/>
           <p:cNvSpPr txBox="1"/>
           <p:nvPr/>
         </p:nvSpPr>
@@ -15229,7 +15284,7 @@
       </p:sp>
       <p:sp>
         <p:nvSpPr>
-          <p:cNvPr id="37" name="TextBox 36"/>
+          <p:cNvPr id="38" name="TextBox 37"/>
           <p:cNvSpPr txBox="1"/>
           <p:nvPr/>
         </p:nvSpPr>
@@ -15257,7 +15312,7 @@
                 </a:solidFill>
                 <a:latin typeface="Calibri"/>
               </a:rPr>
-              <a:t>S13  ·  16 / 31</a:t>
+              <a:t>D13  ·  16 / 31</a:t>
             </a:r>
           </a:p>
         </p:txBody>
@@ -20655,7 +20710,7 @@
                 </a:solidFill>
                 <a:latin typeface="Calibri"/>
               </a:rPr>
-              <a:t>As a letter? a) 14 Q1 rows were deleted as errors; b) the dashboard was right and the books are short; c) 14 Q1 rows are second copies set aside by the order_id rule, and rows and rupees reconcile; d) the 14 rows were outliers.</a:t>
+              <a:t>As a letter? a) 14 Q1 rows were deleted as errors; b) the dashboard was right and the books are short; c) 14 Q1 rows are copies of kept orders, set aside by the order_id rule, and rows and rupees reconcile; d) the 14 rows were outliers.</a:t>
             </a:r>
           </a:p>
         </p:txBody>
@@ -26445,7 +26500,7 @@
                 </a:solidFill>
                 <a:latin typeface="Georgia"/>
               </a:rPr>
-              <a:t>"Your 1.9 crore is right: the export counted fifteen rows twice, and the bridge from 2.1 closes to your books in rows and in rupees. On clean data the drop is 1.6 percent and the Retail-Plus fall is 35 percent, smaller than we reported."</a:t>
+              <a:t>"Your 1.9 crore is right: the export counted fifteen orders twice, and the bridge from 2.1 closes to your books in rows and in rupees. On clean data the drop is 1.6 percent and the Retail-Plus fall is 35 percent, smaller than we reported."</a:t>
             </a:r>
           </a:p>
           <a:p>
@@ -28428,7 +28483,7 @@
                 </a:solidFill>
                 <a:latin typeface="Calibri"/>
               </a:rPr>
-              <a:t>control totals, export to books</a:t>
+              <a:t>control totals: counts and sums at both ends</a:t>
             </a:r>
           </a:p>
         </p:txBody>
@@ -31792,7 +31847,7 @@
                 </a:solidFill>
                 <a:latin typeface="Calibri"/>
               </a:rPr>
-              <a:t>A UK cafe chain's accounting hole reached £94m; the auditor was fined.</a:t>
+              <a:t>A UK cafe chain's accounting hole reached GBP 94m; the auditor was fined.</a:t>
             </a:r>
           </a:p>
         </p:txBody>
@@ -31827,7 +31882,7 @@
                 </a:solidFill>
                 <a:latin typeface="Georgia"/>
               </a:rPr>
-              <a:t>£94m</a:t>
+              <a:t>GBP 94m</a:t>
             </a:r>
           </a:p>
         </p:txBody>
@@ -31976,7 +32031,7 @@
                 </a:solidFill>
                 <a:latin typeface="Georgia"/>
               </a:rPr>
-              <a:t>£4m</a:t>
+              <a:t>GBP 4m</a:t>
             </a:r>
           </a:p>
         </p:txBody>
@@ -32046,7 +32101,7 @@
                 </a:solidFill>
                 <a:latin typeface="Calibri"/>
               </a:rPr>
-              <a:t>reduced to £2.34m</a:t>
+              <a:t>reduced to GBP 2.34m</a:t>
             </a:r>
           </a:p>
         </p:txBody>
@@ -33783,11 +33838,11 @@
         <p:spPr>
           <a:xfrm>
             <a:off x="530352" y="3889248"/>
-            <a:ext cx="11130991" cy="862584"/>
+            <a:ext cx="11130991" cy="807720"/>
           </a:xfrm>
           <a:prstGeom prst="roundRect">
             <a:avLst>
-              <a:gd name="adj" fmla="val 5000"/>
+              <a:gd name="adj" fmla="val 8000"/>
             </a:avLst>
           </a:prstGeom>
           <a:solidFill>
@@ -33798,13 +33853,7 @@
               <a:srgbClr val="E4E1F1"/>
             </a:solidFill>
           </a:ln>
-          <a:effectLst>
-            <a:outerShdw blurRad="76200" dist="19050" dir="5400000" algn="bl" rotWithShape="0">
-              <a:srgbClr val="1A0F5C">
-                <a:alpha val="12000"/>
-              </a:srgbClr>
-            </a:outerShdw>
-          </a:effectLst>
+          <a:effectLst/>
         </p:spPr>
         <p:style>
           <a:lnRef idx="1">
@@ -33830,17 +33879,19 @@
       </p:sp>
       <p:sp>
         <p:nvSpPr>
-          <p:cNvPr id="11" name="Oval 10"/>
+          <p:cNvPr id="11" name="Rounded Rectangle 10"/>
           <p:cNvSpPr/>
           <p:nvPr/>
         </p:nvSpPr>
         <p:spPr>
           <a:xfrm>
-            <a:off x="758952" y="4091940"/>
-            <a:ext cx="457200" cy="457200"/>
-          </a:xfrm>
-          <a:prstGeom prst="ellipse">
-            <a:avLst/>
+            <a:off x="676656" y="4017263"/>
+            <a:ext cx="45720" cy="551688"/>
+          </a:xfrm>
+          <a:prstGeom prst="roundRect">
+            <a:avLst>
+              <a:gd name="adj" fmla="val 50000"/>
+            </a:avLst>
           </a:prstGeom>
           <a:solidFill>
             <a:srgbClr val="5B3FD6"/>
@@ -33872,87 +33923,37 @@
           </a:p>
         </p:txBody>
       </p:sp>
-      <p:pic>
-        <p:nvPicPr>
-          <p:cNvPr id="12" name="Picture 11" descr="search-check_6571e64a041f.png"/>
-          <p:cNvPicPr>
-            <a:picLocks noChangeAspect="1"/>
-          </p:cNvPicPr>
-          <p:nvPr/>
-        </p:nvPicPr>
-        <p:blipFill>
-          <a:blip r:embed="rId4"/>
-          <a:stretch>
-            <a:fillRect/>
-          </a:stretch>
-        </p:blipFill>
-        <p:spPr>
-          <a:xfrm>
-            <a:off x="868680" y="4201668"/>
-            <a:ext cx="237744" cy="237744"/>
-          </a:xfrm>
-          <a:prstGeom prst="rect">
-            <a:avLst/>
-          </a:prstGeom>
-        </p:spPr>
-      </p:pic>
-      <p:sp>
-        <p:nvSpPr>
-          <p:cNvPr id="13" name="TextBox 12"/>
-          <p:cNvSpPr txBox="1"/>
-          <p:nvPr/>
-        </p:nvSpPr>
-        <p:spPr>
-          <a:xfrm>
-            <a:off x="1399031" y="4035552"/>
-            <a:ext cx="9987991" cy="160401"/>
-          </a:xfrm>
-          <a:prstGeom prst="rect">
-            <a:avLst/>
-          </a:prstGeom>
-          <a:noFill/>
-        </p:spPr>
-        <p:txBody>
-          <a:bodyPr wrap="square" anchor="t" lIns="0" rIns="0" tIns="0" bIns="0">
-            <a:spAutoFit/>
-          </a:bodyPr>
-          <a:lstStyle/>
-          <a:p>
-            <a:pPr algn="l"/>
-            <a:r>
-              <a:rPr sz="750" b="1" i="0" spc="250">
+      <p:sp>
+        <p:nvSpPr>
+          <p:cNvPr id="12" name="TextBox 11"/>
+          <p:cNvSpPr txBox="1"/>
+          <p:nvPr/>
+        </p:nvSpPr>
+        <p:spPr>
+          <a:xfrm>
+            <a:off x="877824" y="4008119"/>
+            <a:ext cx="10564063" cy="624840"/>
+          </a:xfrm>
+          <a:prstGeom prst="rect">
+            <a:avLst/>
+          </a:prstGeom>
+          <a:noFill/>
+        </p:spPr>
+        <p:txBody>
+          <a:bodyPr wrap="square" anchor="ctr" lIns="0" rIns="0" tIns="0" bIns="0">
+            <a:spAutoFit/>
+          </a:bodyPr>
+          <a:lstStyle/>
+          <a:p>
+            <a:r>
+              <a:rPr sz="1500" b="1">
                 <a:solidFill>
                   <a:srgbClr val="5B3FD6"/>
                 </a:solidFill>
                 <a:latin typeface="Calibri"/>
               </a:rPr>
-              <a:t>KAVYA'S REVIEW</a:t>
-            </a:r>
-          </a:p>
-        </p:txBody>
-      </p:sp>
-      <p:sp>
-        <p:nvSpPr>
-          <p:cNvPr id="14" name="TextBox 13"/>
-          <p:cNvSpPr txBox="1"/>
-          <p:nvPr/>
-        </p:nvSpPr>
-        <p:spPr>
-          <a:xfrm>
-            <a:off x="1399031" y="4255008"/>
-            <a:ext cx="9987991" cy="423672"/>
-          </a:xfrm>
-          <a:prstGeom prst="rect">
-            <a:avLst/>
-          </a:prstGeom>
-          <a:noFill/>
-        </p:spPr>
-        <p:txBody>
-          <a:bodyPr wrap="square" anchor="t" lIns="0" rIns="0" tIns="0" bIns="0">
-            <a:spAutoFit/>
-          </a:bodyPr>
-          <a:lstStyle/>
-          <a:p>
+              <a:t>The call. </a:t>
+            </a:r>
             <a:r>
               <a:rPr sz="1500" b="0" i="0">
                 <a:solidFill>
@@ -33967,7 +33968,7 @@
       </p:sp>
       <p:sp>
         <p:nvSpPr>
-          <p:cNvPr id="15" name="Oval 14"/>
+          <p:cNvPr id="13" name="Oval 12"/>
           <p:cNvSpPr/>
           <p:nvPr/>
         </p:nvSpPr>
@@ -34011,7 +34012,7 @@
       </p:sp>
       <p:sp>
         <p:nvSpPr>
-          <p:cNvPr id="16" name="TextBox 15"/>
+          <p:cNvPr id="14" name="TextBox 13"/>
           <p:cNvSpPr txBox="1"/>
           <p:nvPr/>
         </p:nvSpPr>
@@ -34046,7 +34047,7 @@
       </p:sp>
       <p:sp>
         <p:nvSpPr>
-          <p:cNvPr id="17" name="Oval 16"/>
+          <p:cNvPr id="15" name="Oval 14"/>
           <p:cNvSpPr/>
           <p:nvPr/>
         </p:nvSpPr>
@@ -34090,7 +34091,7 @@
       </p:sp>
       <p:sp>
         <p:nvSpPr>
-          <p:cNvPr id="18" name="TextBox 17"/>
+          <p:cNvPr id="16" name="TextBox 15"/>
           <p:cNvSpPr txBox="1"/>
           <p:nvPr/>
         </p:nvSpPr>
@@ -34125,7 +34126,7 @@
       </p:sp>
       <p:sp>
         <p:nvSpPr>
-          <p:cNvPr id="19" name="Oval 18"/>
+          <p:cNvPr id="17" name="Oval 16"/>
           <p:cNvSpPr/>
           <p:nvPr/>
         </p:nvSpPr>
@@ -34169,7 +34170,7 @@
       </p:sp>
       <p:sp>
         <p:nvSpPr>
-          <p:cNvPr id="20" name="TextBox 19"/>
+          <p:cNvPr id="18" name="TextBox 17"/>
           <p:cNvSpPr txBox="1"/>
           <p:nvPr/>
         </p:nvSpPr>
@@ -34204,7 +34205,7 @@
       </p:sp>
       <p:sp>
         <p:nvSpPr>
-          <p:cNvPr id="21" name="Oval 20"/>
+          <p:cNvPr id="19" name="Oval 18"/>
           <p:cNvSpPr/>
           <p:nvPr/>
         </p:nvSpPr>
@@ -34248,7 +34249,7 @@
       </p:sp>
       <p:sp>
         <p:nvSpPr>
-          <p:cNvPr id="22" name="TextBox 21"/>
+          <p:cNvPr id="20" name="TextBox 19"/>
           <p:cNvSpPr txBox="1"/>
           <p:nvPr/>
         </p:nvSpPr>
@@ -34283,7 +34284,7 @@
       </p:sp>
       <p:sp>
         <p:nvSpPr>
-          <p:cNvPr id="23" name="Oval 22"/>
+          <p:cNvPr id="21" name="Oval 20"/>
           <p:cNvSpPr/>
           <p:nvPr/>
         </p:nvSpPr>
@@ -34327,7 +34328,7 @@
       </p:sp>
       <p:sp>
         <p:nvSpPr>
-          <p:cNvPr id="24" name="TextBox 23"/>
+          <p:cNvPr id="22" name="TextBox 21"/>
           <p:cNvSpPr txBox="1"/>
           <p:nvPr/>
         </p:nvSpPr>
@@ -34362,7 +34363,7 @@
       </p:sp>
       <p:sp>
         <p:nvSpPr>
-          <p:cNvPr id="25" name="Oval 24"/>
+          <p:cNvPr id="23" name="Oval 22"/>
           <p:cNvSpPr/>
           <p:nvPr/>
         </p:nvSpPr>
@@ -34406,7 +34407,7 @@
       </p:sp>
       <p:sp>
         <p:nvSpPr>
-          <p:cNvPr id="26" name="TextBox 25"/>
+          <p:cNvPr id="24" name="TextBox 23"/>
           <p:cNvSpPr txBox="1"/>
           <p:nvPr/>
         </p:nvSpPr>
@@ -34441,7 +34442,7 @@
       </p:sp>
       <p:sp>
         <p:nvSpPr>
-          <p:cNvPr id="27" name="TextBox 26"/>
+          <p:cNvPr id="25" name="TextBox 24"/>
           <p:cNvSpPr txBox="1"/>
           <p:nvPr/>
         </p:nvSpPr>

</xml_diff>

<commit_message>
W01 D3: depth loop round two fixes: no take-home plant in class items, Target wording to its source, the Week 5 reference removed, S40 and S56 carry their decisions, honest design tags, glossary prints fence and control totals
</commit_message>
<xml_diff>
--- a/content/W01/D3/slides/C2_W01_D03_half2_STUDENT.pptx
+++ b/content/W01/D3/slides/C2_W01_D03_half2_STUDENT.pptx
@@ -15588,7 +15588,7 @@
                 </a:solidFill>
                 <a:latin typeface="Calibri"/>
               </a:rPr>
-              <a:t>Fifteen minutes on the numbers the room produced, each traced to the step that made it.</a:t>
+              <a:t>Every wrong number traced to the step that made it and the check that catches it.</a:t>
             </a:r>
           </a:p>
         </p:txBody>
@@ -17611,7 +17611,7 @@
       </p:sp>
       <p:pic>
         <p:nvPicPr>
-          <p:cNvPr id="12" name="Picture 11" descr="search-check_6571e64a041f.png"/>
+          <p:cNvPr id="12" name="Picture 11" descr="list-checks_bd88901d2a37.png"/>
           <p:cNvPicPr>
             <a:picLocks noChangeAspect="1"/>
           </p:cNvPicPr>
@@ -17663,7 +17663,7 @@
                 </a:solidFill>
                 <a:latin typeface="Calibri"/>
               </a:rPr>
-              <a:t>KAVYA'S REVIEW</a:t>
+              <a:t>THE RULE</a:t>
             </a:r>
           </a:p>
         </p:txBody>
@@ -20710,7 +20710,7 @@
                 </a:solidFill>
                 <a:latin typeface="Calibri"/>
               </a:rPr>
-              <a:t>As a letter? a) 14 Q1 rows were deleted as errors; b) the dashboard was right and the books are short; c) 14 Q1 rows are copies of kept orders, set aside by the order_id rule, and rows and rupees reconcile; d) the 14 rows were outliers.</a:t>
+              <a:t>As a letter? a) 14 Q1 rows were deleted as errors after the migration check; b) the dashboard was right all along, and the books are short; c) 14 Q1 rows are copies of kept orders, set aside by rule, and both totals tie; d) the 14 rows were outliers removed to keep Q1 in line with Q2.</a:t>
             </a:r>
           </a:p>
         </p:txBody>
@@ -22036,7 +22036,7 @@
       </p:sp>
       <p:pic>
         <p:nvPicPr>
-          <p:cNvPr id="23" name="Picture 22" descr="search-check_6571e64a041f.png"/>
+          <p:cNvPr id="23" name="Picture 22" descr="list-checks_bd88901d2a37.png"/>
           <p:cNvPicPr>
             <a:picLocks noChangeAspect="1"/>
           </p:cNvPicPr>
@@ -22088,7 +22088,7 @@
                 </a:solidFill>
                 <a:latin typeface="Calibri"/>
               </a:rPr>
-              <a:t>KAVYA'S REVIEW</a:t>
+              <a:t>THE RULE</a:t>
             </a:r>
           </a:p>
         </p:txBody>
@@ -33259,11 +33259,11 @@
                 <a:tableStyleId>{2D5ABB26-0587-4C30-8999-92F81FD0307C}</a:tableStyleId>
               </a:tblPr>
               <a:tblGrid>
-                <a:gridCol w="4157476"/>
+                <a:gridCol w="5098215"/>
                 <a:gridCol w="914400"/>
-                <a:gridCol w="1857927"/>
-                <a:gridCol w="2181482"/>
-                <a:gridCol w="2019704"/>
+                <a:gridCol w="1569465"/>
+                <a:gridCol w="1842784"/>
+                <a:gridCol w="1706125"/>
               </a:tblGrid>
               <a:tr h="335280">
                 <a:tc>
@@ -33390,7 +33390,7 @@
                           </a:solidFill>
                           <a:latin typeface="Calibri"/>
                         </a:rPr>
-                        <a:t>a) The clean file alone</a:t>
+                        <a:t>a) The clean file, read against the raw</a:t>
                       </a:r>
                     </a:p>
                   </a:txBody>
@@ -33792,7 +33792,7 @@
                           </a:solidFill>
                           <a:latin typeface="Calibri"/>
                         </a:rPr>
-                        <a:t>no</a:t>
+                        <a:t>by hand</a:t>
                       </a:r>
                     </a:p>
                   </a:txBody>

</xml_diff>

<commit_message>
W01 D3: pass 4 round three fixes: the bulk order enters the flags log, company wording held to the sourced facts, interview answers carry the model side and blocking's cost; the depth loop closes
</commit_message>
<xml_diff>
--- a/content/W01/D3/slides/C2_W01_D03_half2_STUDENT.pptx
+++ b/content/W01/D3/slides/C2_W01_D03_half2_STUDENT.pptx
@@ -2432,7 +2432,7 @@
           <a:lstStyle/>
           <a:p>
             <a:r>
-              <a:t>LIVE, 5 minutes. 23 lines: 15 set-aside rows, 1 flag, 5 decisions, 2 control totals, and an empty</a:t>
+              <a:t>LIVE, 5 minutes. 24 lines: 15 set-aside rows, 2 flags (the status and the bulk order), 5 decisions, 2 control totals, and an empty</a:t>
             </a:r>
           </a:p>
           <a:p>
@@ -33434,7 +33434,7 @@
                           </a:solidFill>
                           <a:latin typeface="Calibri"/>
                         </a:rPr>
-                        <a:t>no</a:t>
+                        <a:t>by hand</a:t>
                       </a:r>
                     </a:p>
                   </a:txBody>
@@ -33636,7 +33636,7 @@
                           </a:solidFill>
                           <a:latin typeface="Calibri"/>
                         </a:rPr>
-                        <a:t>23</a:t>
+                        <a:t>24</a:t>
                       </a:r>
                     </a:p>
                   </a:txBody>
@@ -36650,7 +36650,7 @@
                 </a:solidFill>
                 <a:latin typeface="Calibri"/>
               </a:rPr>
-              <a:t>57 rows flagged or kept</a:t>
+              <a:t>58 rows flagged or kept</a:t>
             </a:r>
           </a:p>
         </p:txBody>

</xml_diff>